<commit_message>
sd-12-011..015: show the programs behind the numbers, rerun-exact offline figures, honest mobile status, README list spacing
Co-Authored-By: Claude Sonnet 5.5 <noreply@anthropic.com>
Claude-Session: https://claude.ai/code/session_01YWnTQqPDLSbUsxkfwNWsvG
</commit_message>
<xml_diff>
--- a/system-design-101/vi/lessons/sd-12-015/slides/sd-12-015.pptx
+++ b/system-design-101/vi/lessons/sd-12-015/slides/sd-12-015.pptx
@@ -6793,7 +6793,7 @@
                 <a:ea typeface="Be Vietnam Pro" pitchFamily="34" charset="-122"/>
                 <a:cs typeface="Be Vietnam Pro" pitchFamily="34" charset="-120"/>
               </a:rPr>
-              <a:t>92,1%</a:t>
+              <a:t>92,5%</a:t>
             </a:r>
             <a:endParaRPr lang="en-US" sz="2400" dirty="0"/>
           </a:p>
@@ -6948,7 +6948,7 @@
                 <a:ea typeface="Be Vietnam Pro" pitchFamily="34" charset="-122"/>
                 <a:cs typeface="Be Vietnam Pro" pitchFamily="34" charset="-120"/>
               </a:rPr>
-              <a:t>15,8%</a:t>
+              <a:t>16,5%</a:t>
             </a:r>
             <a:endParaRPr lang="en-US" sz="2400" dirty="0"/>
           </a:p>

</xml_diff>

<commit_message>
sd-12-011, sd-12-015: uncorrelated assignment is not no interference; offline lifetime model measures age from send time
Co-Authored-By: Claude Sonnet 5.5 <noreply@anthropic.com>
Claude-Session: https://claude.ai/code/session_01YWnTQqPDLSbUsxkfwNWsvG
</commit_message>
<xml_diff>
--- a/system-design-101/vi/lessons/sd-12-015/slides/sd-12-015.pptx
+++ b/system-design-101/vi/lessons/sd-12-015/slides/sd-12-015.pptx
@@ -6785,7 +6785,7 @@
               <a:buNone/>
             </a:pPr>
             <a:r>
-              <a:rPr lang="en-US" sz="2400" dirty="0" spc="-1" kern="0">
+              <a:rPr lang="en-US" sz="2400" dirty="0" spc="-24" kern="0">
                 <a:solidFill>
                   <a:srgbClr val="F3EEE3"/>
                 </a:solidFill>
@@ -6793,7 +6793,7 @@
                 <a:ea typeface="Be Vietnam Pro" pitchFamily="34" charset="-122"/>
                 <a:cs typeface="Be Vietnam Pro" pitchFamily="34" charset="-120"/>
               </a:rPr>
-              <a:t>92,5%</a:t>
+              <a:t>64,7%</a:t>
             </a:r>
             <a:endParaRPr lang="en-US" sz="2400" dirty="0"/>
           </a:p>
@@ -7103,7 +7103,7 @@
                 <a:ea typeface="Be Vietnam Pro" pitchFamily="34" charset="-122"/>
                 <a:cs typeface="Be Vietnam Pro" pitchFamily="34" charset="-120"/>
               </a:rPr>
-              <a:t>0%</a:t>
+              <a:t>5,8%</a:t>
             </a:r>
             <a:endParaRPr lang="en-US" sz="2400" dirty="0"/>
           </a:p>
@@ -7173,6 +7173,28 @@
               <a:buNone/>
             </a:pPr>
             <a:r>
+              <a:rPr lang="en-US" sz="2700" dirty="0" spc="1" kern="0">
+                <a:solidFill>
+                  <a:srgbClr val="F3EEE3"/>
+                </a:solidFill>
+                <a:latin typeface="Be Vietnam Pro" pitchFamily="34" charset="0"/>
+                <a:ea typeface="Be Vietnam Pro" pitchFamily="34" charset="-122"/>
+                <a:cs typeface="Be Vietnam Pro" pitchFamily="34" charset="-120"/>
+              </a:rPr>
+              <a:t>Tin</a:t>
+            </a:r>
+            <a:r>
+              <a:rPr lang="en-US" sz="2700" dirty="0" spc="41" kern="0">
+                <a:solidFill>
+                  <a:srgbClr val="F3EEE3"/>
+                </a:solidFill>
+                <a:latin typeface="Be Vietnam Pro" pitchFamily="34" charset="0"/>
+                <a:ea typeface="Be Vietnam Pro" pitchFamily="34" charset="-122"/>
+                <a:cs typeface="Be Vietnam Pro" pitchFamily="34" charset="-120"/>
+              </a:rPr>
+              <a:t> gửi</a:t>
+            </a:r>
+            <a:r>
               <a:rPr lang="en-US" sz="2700" dirty="0" spc="0" kern="0">
                 <a:solidFill>
                   <a:srgbClr val="F3EEE3"/>
@@ -7181,7 +7203,40 @@
                 <a:ea typeface="Be Vietnam Pro" pitchFamily="34" charset="-122"/>
                 <a:cs typeface="Be Vietnam Pro" pitchFamily="34" charset="-120"/>
               </a:rPr>
-              <a:t>Hạn</a:t>
+              <a:t> lúc</a:t>
+            </a:r>
+            <a:r>
+              <a:rPr lang="en-US" sz="2700" dirty="0" spc="-12" kern="0">
+                <a:solidFill>
+                  <a:srgbClr val="F3EEE3"/>
+                </a:solidFill>
+                <a:latin typeface="Be Vietnam Pro" pitchFamily="34" charset="0"/>
+                <a:ea typeface="Be Vietnam Pro" pitchFamily="34" charset="-122"/>
+                <a:cs typeface="Be Vietnam Pro" pitchFamily="34" charset="-120"/>
+              </a:rPr>
+              <a:t> máy</a:t>
+            </a:r>
+            <a:r>
+              <a:rPr lang="en-US" sz="2700" dirty="0" spc="-13" kern="0">
+                <a:solidFill>
+                  <a:srgbClr val="F3EEE3"/>
+                </a:solidFill>
+                <a:latin typeface="Be Vietnam Pro" pitchFamily="34" charset="0"/>
+                <a:ea typeface="Be Vietnam Pro" pitchFamily="34" charset="-122"/>
+                <a:cs typeface="Be Vietnam Pro" pitchFamily="34" charset="-120"/>
+              </a:rPr>
+              <a:t> ngoại tuyến;</a:t>
+            </a:r>
+            <a:r>
+              <a:rPr lang="en-US" sz="2700" dirty="0" spc="-2" kern="0">
+                <a:solidFill>
+                  <a:srgbClr val="F3EEE3"/>
+                </a:solidFill>
+                <a:latin typeface="Be Vietnam Pro" pitchFamily="34" charset="0"/>
+                <a:ea typeface="Be Vietnam Pro" pitchFamily="34" charset="-122"/>
+                <a:cs typeface="Be Vietnam Pro" pitchFamily="34" charset="-120"/>
+              </a:rPr>
+              <a:t> hạn</a:t>
             </a:r>
             <a:r>
               <a:rPr lang="en-US" sz="2700" dirty="0" spc="-8" kern="0">
@@ -7195,6 +7250,17 @@
               <a:t> sống</a:t>
             </a:r>
             <a:r>
+              <a:rPr lang="en-US" sz="2700" dirty="0" spc="-2" kern="0">
+                <a:solidFill>
+                  <a:srgbClr val="F3EEE3"/>
+                </a:solidFill>
+                <a:latin typeface="Be Vietnam Pro" pitchFamily="34" charset="0"/>
+                <a:ea typeface="Be Vietnam Pro" pitchFamily="34" charset="-122"/>
+                <a:cs typeface="Be Vietnam Pro" pitchFamily="34" charset="-120"/>
+              </a:rPr>
+              <a:t> là</a:t>
+            </a:r>
+            <a:r>
               <a:rPr lang="en-US" sz="2700" dirty="0" spc="-1" kern="0">
                 <a:solidFill>
                   <a:srgbClr val="F3EEE3"/>
@@ -7203,7 +7269,7 @@
                 <a:ea typeface="Be Vietnam Pro" pitchFamily="34" charset="-122"/>
                 <a:cs typeface="Be Vietnam Pro" pitchFamily="34" charset="-120"/>
               </a:rPr>
-              <a:t> là tham</a:t>
+              <a:t> tham</a:t>
             </a:r>
             <a:r>
               <a:rPr lang="en-US" sz="2700" dirty="0" spc="-12" kern="0">

</xml_diff>

<commit_message>
sd-12-015: both cleanup policies on the same churn history; offline figures rerun; oracle caveat
Co-Authored-By: Claude Sonnet 5.5 <noreply@anthropic.com>
Claude-Session: https://claude.ai/code/session_01YWnTQqPDLSbUsxkfwNWsvG
</commit_message>
<xml_diff>
--- a/system-design-101/vi/lessons/sd-12-015/slides/sd-12-015.pptx
+++ b/system-design-101/vi/lessons/sd-12-015/slides/sd-12-015.pptx
@@ -4083,7 +4083,7 @@
               <a:buNone/>
             </a:pPr>
             <a:r>
-              <a:rPr lang="en-US" sz="7200" dirty="0" spc="-4" kern="0">
+              <a:rPr lang="en-US" sz="7200" dirty="0" spc="-63" kern="0">
                 <a:solidFill>
                   <a:srgbClr val="F3EEE3"/>
                 </a:solidFill>
@@ -4091,7 +4091,7 @@
                 <a:ea typeface="Bricolage Grotesque ExtraBold" pitchFamily="34" charset="-122"/>
                 <a:cs typeface="Bricolage Grotesque ExtraBold" pitchFamily="34" charset="-120"/>
               </a:rPr>
-              <a:t>78.300</a:t>
+              <a:t>78.547</a:t>
             </a:r>
             <a:endParaRPr lang="en-US" sz="7200" dirty="0"/>
           </a:p>
@@ -4210,7 +4210,7 @@
               <a:buNone/>
             </a:pPr>
             <a:r>
-              <a:rPr lang="en-US" sz="7200" dirty="0" spc="-41" kern="0">
+              <a:rPr lang="en-US" sz="7200" dirty="0" spc="5" kern="0">
                 <a:solidFill>
                   <a:srgbClr val="FF6A4D"/>
                 </a:solidFill>
@@ -4218,7 +4218,7 @@
                 <a:ea typeface="Bricolage Grotesque ExtraBold" pitchFamily="34" charset="-122"/>
                 <a:cs typeface="Bricolage Grotesque ExtraBold" pitchFamily="34" charset="-120"/>
               </a:rPr>
-              <a:t>4.014</a:t>
+              <a:t>3.844</a:t>
             </a:r>
             <a:endParaRPr lang="en-US" sz="7200" dirty="0"/>
           </a:p>
@@ -6785,7 +6785,7 @@
               <a:buNone/>
             </a:pPr>
             <a:r>
-              <a:rPr lang="en-US" sz="2400" dirty="0" spc="-24" kern="0">
+              <a:rPr lang="en-US" sz="2400" dirty="0" spc="-2" kern="0">
                 <a:solidFill>
                   <a:srgbClr val="F3EEE3"/>
                 </a:solidFill>
@@ -6793,7 +6793,7 @@
                 <a:ea typeface="Be Vietnam Pro" pitchFamily="34" charset="-122"/>
                 <a:cs typeface="Be Vietnam Pro" pitchFamily="34" charset="-120"/>
               </a:rPr>
-              <a:t>64,7%</a:t>
+              <a:t>63,9%</a:t>
             </a:r>
             <a:endParaRPr lang="en-US" sz="2400" dirty="0"/>
           </a:p>
@@ -6940,7 +6940,7 @@
               <a:buNone/>
             </a:pPr>
             <a:r>
-              <a:rPr lang="en-US" sz="2400" b="1" dirty="0" spc="2" kern="0">
+              <a:rPr lang="en-US" sz="2400" b="1" dirty="0" spc="1" kern="0">
                 <a:solidFill>
                   <a:srgbClr val="F3EEE3"/>
                 </a:solidFill>
@@ -6948,7 +6948,7 @@
                 <a:ea typeface="Be Vietnam Pro" pitchFamily="34" charset="-122"/>
                 <a:cs typeface="Be Vietnam Pro" pitchFamily="34" charset="-120"/>
               </a:rPr>
-              <a:t>16,5%</a:t>
+              <a:t>17,8%</a:t>
             </a:r>
             <a:endParaRPr lang="en-US" sz="2400" dirty="0"/>
           </a:p>
@@ -7095,7 +7095,7 @@
               <a:buNone/>
             </a:pPr>
             <a:r>
-              <a:rPr lang="en-US" sz="2400" dirty="0" spc="-1" kern="0">
+              <a:rPr lang="en-US" sz="2400" dirty="0" spc="-7" kern="0">
                 <a:solidFill>
                   <a:srgbClr val="F3EEE3"/>
                 </a:solidFill>
@@ -7103,7 +7103,7 @@
                 <a:ea typeface="Be Vietnam Pro" pitchFamily="34" charset="-122"/>
                 <a:cs typeface="Be Vietnam Pro" pitchFamily="34" charset="-120"/>
               </a:rPr>
-              <a:t>5,8%</a:t>
+              <a:t>5,3%</a:t>
             </a:r>
             <a:endParaRPr lang="en-US" sz="2400" dirty="0"/>
           </a:p>

</xml_diff>

<commit_message>
sd-12-015 deck: slide 6 cleanup share 4.7%, PPTX re-exported
Co-Authored-By: Claude Sonnet 5.5 <noreply@anthropic.com>
Claude-Session: https://claude.ai/code/session_01YWnTQqPDLSbUsxkfwNWsvG
</commit_message>
<xml_diff>
--- a/system-design-101/vi/lessons/sd-12-015/slides/sd-12-015.pptx
+++ b/system-design-101/vi/lessons/sd-12-015/slides/sd-12-015.pptx
@@ -8245,7 +8245,7 @@
               <a:t> còn</a:t>
             </a:r>
             <a:r>
-              <a:rPr lang="en-US" sz="2550" b="1" dirty="0" spc="-2" kern="0">
+              <a:rPr lang="en-US" sz="2550" b="1" dirty="0" spc="-12" kern="0">
                 <a:solidFill>
                   <a:srgbClr val="14161C"/>
                 </a:solidFill>
@@ -8253,7 +8253,7 @@
                 <a:ea typeface="Be Vietnam Pro" pitchFamily="34" charset="-122"/>
                 <a:cs typeface="Be Vietnam Pro" pitchFamily="34" charset="-120"/>
               </a:rPr>
-              <a:t> 4,9%</a:t>
+              <a:t> 4,7%</a:t>
             </a:r>
             <a:endParaRPr lang="en-US" sz="2550" dirty="0"/>
           </a:p>

</xml_diff>

<commit_message>
sd-12-015 deck: slides 3 and 6 carry the oracle-cleanup caveat; PPTX re-exported
Co-Authored-By: Claude Sonnet 5.5 <noreply@anthropic.com>
Claude-Session: https://claude.ai/code/session_01YWnTQqPDLSbUsxkfwNWsvG
</commit_message>
<xml_diff>
--- a/system-design-101/vi/lessons/sd-12-015/slides/sd-12-015.pptx
+++ b/system-design-101/vi/lessons/sd-12-015/slides/sd-12-015.pptx
@@ -4299,7 +4299,7 @@
               <a:buNone/>
             </a:pPr>
             <a:r>
-              <a:rPr lang="en-US" sz="2250" dirty="0" spc="-2" kern="0">
+              <a:rPr lang="en-US" sz="2250" dirty="0" spc="-1" kern="0">
                 <a:solidFill>
                   <a:srgbClr val="9AA0B5"/>
                 </a:solidFill>
@@ -4307,10 +4307,10 @@
                 <a:ea typeface="Be Vietnam Pro" pitchFamily="34" charset="-122"/>
                 <a:cs typeface="Be Vietnam Pro" pitchFamily="34" charset="-120"/>
               </a:rPr>
-              <a:t>Tham</a:t>
-            </a:r>
-            <a:r>
-              <a:rPr lang="en-US" sz="2250" dirty="0" spc="-3" kern="0">
+              <a:t>Mô</a:t>
+            </a:r>
+            <a:r>
+              <a:rPr lang="en-US" sz="2250" dirty="0" spc="2" kern="0">
                 <a:solidFill>
                   <a:srgbClr val="9AA0B5"/>
                 </a:solidFill>
@@ -4318,10 +4318,10 @@
                 <a:ea typeface="Be Vietnam Pro" pitchFamily="34" charset="-122"/>
                 <a:cs typeface="Be Vietnam Pro" pitchFamily="34" charset="-120"/>
               </a:rPr>
-              <a:t> số</a:t>
-            </a:r>
-            <a:r>
-              <a:rPr lang="en-US" sz="2250" dirty="0" spc="2" kern="0">
+              <a:t> phỏng</a:t>
+            </a:r>
+            <a:r>
+              <a:rPr lang="en-US" sz="2250" dirty="0" spc="-5" kern="0">
                 <a:solidFill>
                   <a:srgbClr val="9AA0B5"/>
                 </a:solidFill>
@@ -4329,7 +4329,62 @@
                 <a:ea typeface="Be Vietnam Pro" pitchFamily="34" charset="-122"/>
                 <a:cs typeface="Be Vietnam Pro" pitchFamily="34" charset="-120"/>
               </a:rPr>
-              <a:t> của mô</a:t>
+              <a:t> biết</a:t>
+            </a:r>
+            <a:r>
+              <a:rPr lang="en-US" sz="2250" dirty="0" spc="7" kern="0">
+                <a:solidFill>
+                  <a:srgbClr val="9AA0B5"/>
+                </a:solidFill>
+                <a:latin typeface="Be Vietnam Pro" pitchFamily="34" charset="0"/>
+                <a:ea typeface="Be Vietnam Pro" pitchFamily="34" charset="-122"/>
+                <a:cs typeface="Be Vietnam Pro" pitchFamily="34" charset="-120"/>
+              </a:rPr>
+              <a:t> trước</a:t>
+            </a:r>
+            <a:r>
+              <a:rPr lang="en-US" sz="2250" dirty="0" spc="0" kern="0">
+                <a:solidFill>
+                  <a:srgbClr val="9AA0B5"/>
+                </a:solidFill>
+                <a:latin typeface="Be Vietnam Pro" pitchFamily="34" charset="0"/>
+                <a:ea typeface="Be Vietnam Pro" pitchFamily="34" charset="-122"/>
+                <a:cs typeface="Be Vietnam Pro" pitchFamily="34" charset="-120"/>
+              </a:rPr>
+              <a:t> thẻ</a:t>
+            </a:r>
+            <a:r>
+              <a:rPr lang="en-US" sz="2250" dirty="0" spc="-1" kern="0">
+                <a:solidFill>
+                  <a:srgbClr val="9AA0B5"/>
+                </a:solidFill>
+                <a:latin typeface="Be Vietnam Pro" pitchFamily="34" charset="0"/>
+                <a:ea typeface="Be Vietnam Pro" pitchFamily="34" charset="-122"/>
+                <a:cs typeface="Be Vietnam Pro" pitchFamily="34" charset="-120"/>
+              </a:rPr>
+              <a:t> nào</a:t>
+            </a:r>
+            <a:r>
+              <a:rPr lang="en-US" sz="2250" dirty="0" spc="-4" kern="0">
+                <a:solidFill>
+                  <a:srgbClr val="9AA0B5"/>
+                </a:solidFill>
+                <a:latin typeface="Be Vietnam Pro" pitchFamily="34" charset="0"/>
+                <a:ea typeface="Be Vietnam Pro" pitchFamily="34" charset="-122"/>
+                <a:cs typeface="Be Vietnam Pro" pitchFamily="34" charset="-120"/>
+              </a:rPr>
+              <a:t> chết;</a:t>
+            </a:r>
+            <a:r>
+              <a:rPr lang="en-US" sz="2250" dirty="0" spc="-1" kern="0">
+                <a:solidFill>
+                  <a:srgbClr val="9AA0B5"/>
+                </a:solidFill>
+                <a:latin typeface="Be Vietnam Pro" pitchFamily="34" charset="0"/>
+                <a:ea typeface="Be Vietnam Pro" pitchFamily="34" charset="-122"/>
+                <a:cs typeface="Be Vietnam Pro" pitchFamily="34" charset="-120"/>
+              </a:rPr>
+              <a:t> hệ</a:t>
             </a:r>
             <a:r>
               <a:rPr lang="en-US" sz="2250" dirty="0" spc="1" kern="0">
@@ -4340,10 +4395,10 @@
                 <a:ea typeface="Be Vietnam Pro" pitchFamily="34" charset="-122"/>
                 <a:cs typeface="Be Vietnam Pro" pitchFamily="34" charset="-120"/>
               </a:rPr>
-              <a:t> phỏng, không</a:t>
-            </a:r>
-            <a:r>
-              <a:rPr lang="en-US" sz="2250" dirty="0" spc="-1" kern="0">
+              <a:t> thống</a:t>
+            </a:r>
+            <a:r>
+              <a:rPr lang="en-US" sz="2250" dirty="0" spc="-9" kern="0">
                 <a:solidFill>
                   <a:srgbClr val="9AA0B5"/>
                 </a:solidFill>
@@ -4351,10 +4406,10 @@
                 <a:ea typeface="Be Vietnam Pro" pitchFamily="34" charset="-122"/>
                 <a:cs typeface="Be Vietnam Pro" pitchFamily="34" charset="-120"/>
               </a:rPr>
-              <a:t> phải</a:t>
-            </a:r>
-            <a:r>
-              <a:rPr lang="en-US" sz="2250" dirty="0" spc="-2" kern="0">
+              <a:t> thật</a:t>
+            </a:r>
+            <a:r>
+              <a:rPr lang="en-US" sz="2250" dirty="0" spc="5" kern="0">
                 <a:solidFill>
                   <a:srgbClr val="9AA0B5"/>
                 </a:solidFill>
@@ -4362,10 +4417,10 @@
                 <a:ea typeface="Be Vietnam Pro" pitchFamily="34" charset="-122"/>
                 <a:cs typeface="Be Vietnam Pro" pitchFamily="34" charset="-120"/>
               </a:rPr>
-              <a:t> số</a:t>
-            </a:r>
-            <a:r>
-              <a:rPr lang="en-US" sz="2250" dirty="0" spc="16" kern="0">
+              <a:t> có</a:t>
+            </a:r>
+            <a:r>
+              <a:rPr lang="en-US" sz="2250" dirty="0" spc="0" kern="0">
                 <a:solidFill>
                   <a:srgbClr val="9AA0B5"/>
                 </a:solidFill>
@@ -4373,10 +4428,10 @@
                 <a:ea typeface="Be Vietnam Pro" pitchFamily="34" charset="-122"/>
                 <a:cs typeface="Be Vietnam Pro" pitchFamily="34" charset="-120"/>
               </a:rPr>
-              <a:t> đo</a:t>
-            </a:r>
-            <a:r>
-              <a:rPr lang="en-US" sz="2250" dirty="0" spc="2" kern="0">
+              <a:t> thể</a:t>
+            </a:r>
+            <a:r>
+              <a:rPr lang="en-US" sz="2250" dirty="0" spc="-20" kern="0">
                 <a:solidFill>
                   <a:srgbClr val="9AA0B5"/>
                 </a:solidFill>
@@ -4384,10 +4439,10 @@
                 <a:ea typeface="Be Vietnam Pro" pitchFamily="34" charset="-122"/>
                 <a:cs typeface="Be Vietnam Pro" pitchFamily="34" charset="-120"/>
               </a:rPr>
-              <a:t> của</a:t>
-            </a:r>
-            <a:r>
-              <a:rPr lang="en-US" sz="2250" dirty="0" spc="-10" kern="0">
+              <a:t> xóa</a:t>
+            </a:r>
+            <a:r>
+              <a:rPr lang="en-US" sz="2250" dirty="0" spc="1" kern="0">
                 <a:solidFill>
                   <a:srgbClr val="9AA0B5"/>
                 </a:solidFill>
@@ -4395,7 +4450,7 @@
                 <a:ea typeface="Be Vietnam Pro" pitchFamily="34" charset="-122"/>
                 <a:cs typeface="Be Vietnam Pro" pitchFamily="34" charset="-120"/>
               </a:rPr>
-              <a:t> FCM.</a:t>
+              <a:t> nhầm.</a:t>
             </a:r>
             <a:endParaRPr lang="en-US" sz="2250" dirty="0"/>
           </a:p>
@@ -8314,7 +8369,51 @@
                 <a:ea typeface="Be Vietnam Pro" pitchFamily="34" charset="-122"/>
                 <a:cs typeface="Be Vietnam Pro" pitchFamily="34" charset="-120"/>
               </a:rPr>
-              <a:t>Thẻ</a:t>
+              <a:t>Mô</a:t>
+            </a:r>
+            <a:r>
+              <a:rPr lang="en-US" sz="2550" b="1" dirty="0" spc="-8" kern="0">
+                <a:solidFill>
+                  <a:srgbClr val="14161C"/>
+                </a:solidFill>
+                <a:latin typeface="Be Vietnam Pro" pitchFamily="34" charset="0"/>
+                <a:ea typeface="Be Vietnam Pro" pitchFamily="34" charset="-122"/>
+                <a:cs typeface="Be Vietnam Pro" pitchFamily="34" charset="-120"/>
+              </a:rPr>
+              <a:t> phỏng</a:t>
+            </a:r>
+            <a:r>
+              <a:rPr lang="en-US" sz="2550" b="1" dirty="0" spc="-3" kern="0">
+                <a:solidFill>
+                  <a:srgbClr val="14161C"/>
+                </a:solidFill>
+                <a:latin typeface="Be Vietnam Pro" pitchFamily="34" charset="0"/>
+                <a:ea typeface="Be Vietnam Pro" pitchFamily="34" charset="-122"/>
+                <a:cs typeface="Be Vietnam Pro" pitchFamily="34" charset="-120"/>
+              </a:rPr>
+              <a:t> biết</a:t>
+            </a:r>
+            <a:r>
+              <a:rPr lang="en-US" sz="2550" b="1" dirty="0" spc="9" kern="0">
+                <a:solidFill>
+                  <a:srgbClr val="14161C"/>
+                </a:solidFill>
+                <a:latin typeface="Be Vietnam Pro" pitchFamily="34" charset="0"/>
+                <a:ea typeface="Be Vietnam Pro" pitchFamily="34" charset="-122"/>
+                <a:cs typeface="Be Vietnam Pro" pitchFamily="34" charset="-120"/>
+              </a:rPr>
+              <a:t> trước</a:t>
+            </a:r>
+            <a:r>
+              <a:rPr lang="en-US" sz="2550" b="1" dirty="0" spc="-3" kern="0">
+                <a:solidFill>
+                  <a:srgbClr val="14161C"/>
+                </a:solidFill>
+                <a:latin typeface="Be Vietnam Pro" pitchFamily="34" charset="0"/>
+                <a:ea typeface="Be Vietnam Pro" pitchFamily="34" charset="-122"/>
+                <a:cs typeface="Be Vietnam Pro" pitchFamily="34" charset="-120"/>
+              </a:rPr>
+              <a:t> thẻ</a:t>
             </a:r>
             <a:r>
               <a:rPr lang="en-US" sz="2550" b="1" dirty="0" spc="-6" kern="0">
@@ -8325,7 +8424,7 @@
                 <a:ea typeface="Be Vietnam Pro" pitchFamily="34" charset="-122"/>
                 <a:cs typeface="Be Vietnam Pro" pitchFamily="34" charset="-120"/>
               </a:rPr>
-              <a:t> còn</a:t>
+              <a:t> chết,</a:t>
             </a:r>
             <a:r>
               <a:rPr lang="en-US" sz="2550" b="1" dirty="0" spc="-8" kern="0">
@@ -8336,10 +8435,10 @@
                 <a:ea typeface="Be Vietnam Pro" pitchFamily="34" charset="-122"/>
                 <a:cs typeface="Be Vietnam Pro" pitchFamily="34" charset="-120"/>
               </a:rPr>
-              <a:t> sống</a:t>
-            </a:r>
-            <a:r>
-              <a:rPr lang="en-US" sz="2550" b="1" dirty="0" spc="-1" kern="0">
+              <a:t> nên</a:t>
+            </a:r>
+            <a:r>
+              <a:rPr lang="en-US" sz="2550" b="1" dirty="0" spc="-6" kern="0">
                 <a:solidFill>
                   <a:srgbClr val="14161C"/>
                 </a:solidFill>
@@ -8347,10 +8446,10 @@
                 <a:ea typeface="Be Vietnam Pro" pitchFamily="34" charset="-122"/>
                 <a:cs typeface="Be Vietnam Pro" pitchFamily="34" charset="-120"/>
               </a:rPr>
-              <a:t> gần như</a:t>
-            </a:r>
-            <a:r>
-              <a:rPr lang="en-US" sz="2550" b="1" dirty="0" spc="0" kern="0">
+              <a:t> không</a:t>
+            </a:r>
+            <a:r>
+              <a:rPr lang="en-US" sz="2550" b="1" dirty="0" spc="-24" kern="0">
                 <a:solidFill>
                   <a:srgbClr val="14161C"/>
                 </a:solidFill>
@@ -8358,7 +8457,18 @@
                 <a:ea typeface="Be Vietnam Pro" pitchFamily="34" charset="-122"/>
                 <a:cs typeface="Be Vietnam Pro" pitchFamily="34" charset="-120"/>
               </a:rPr>
-              <a:t> nhau</a:t>
+              <a:t> xóa</a:t>
+            </a:r>
+            <a:r>
+              <a:rPr lang="en-US" sz="2550" b="1" dirty="0" spc="-2" kern="0">
+                <a:solidFill>
+                  <a:srgbClr val="14161C"/>
+                </a:solidFill>
+                <a:latin typeface="Be Vietnam Pro" pitchFamily="34" charset="0"/>
+                <a:ea typeface="Be Vietnam Pro" pitchFamily="34" charset="-122"/>
+                <a:cs typeface="Be Vietnam Pro" pitchFamily="34" charset="-120"/>
+              </a:rPr>
+              <a:t> nhầm</a:t>
             </a:r>
             <a:endParaRPr lang="en-US" sz="2550" dirty="0"/>
           </a:p>

</xml_diff>